<commit_message>
Complète la dalle Gustave-Courbet avec les éléments du service Voirie
Co-Authored-By: Claude Opus 5.5 <noreply@anthropic.com>
Claude-Session: https://claude.ai/code/session_019qobuwiwW9YTXEm4C1M654
</commit_message>
<xml_diff>
--- a/reunion_varenne_2026-10-08/Dalle_Gustave_Courbet.pptx
+++ b/reunion_varenne_2026-10-08/Dalle_Gustave_Courbet.pptx
@@ -6,9 +6,10 @@
   </p:sldMasterIdLst>
   <p:sldIdLst>
     <p:sldId id="256" r:id="rId2"/>
+    <p:sldId id="257" r:id="rId3"/>
   </p:sldIdLst>
   <p:notesMasterIdLst>
-    <p:notesMasterId r:id="rId3"/>
+    <p:notesMasterId r:id="rId4"/>
   </p:notesMasterIdLst>
   <p:sldSz cx="12192000" cy="6858000"/>
   <p:notesSz cx="6858000" cy="12192000"/>
@@ -502,7 +503,7 @@
           <a:p>
             <a:r>
               <a:rPr lang="en-US" dirty="0"/>
-              <a:t>Vue aérienne : orthophotographie IGN (Géoplateforme, BD ORTHO, licence ouverte Etalab). Point « Place Gustave Courbet » issu du géocodeur de la Géoplateforme (48,840084 N ; 2,545801 E). Les verrières en forme de croix correspondent aux accès de la gare RER Noisy-le-Grand – Mont d’Est, sous la dalle. La date de la prise de vue est antérieure aux travaux en cours éventuels.</a:t>
+              <a:t>Source : direction de l’Environnement et de l’Espace public, service Voirie (courriel du 12 octobre 2026). Étanchéité d’origine : complexe d’asphalte et de polystyrène extrudé. ATTENTION : le courriel indique que la Ville fait l’objet d’une procédure pénale au sujet des infiltrations dans les commerces. Cette information n’est pas projetée ; ne pas l’évoquer en réunion publique sans l’avis du service juridique.</a:t>
             </a:r>
             <a:endParaRPr lang="en-US" dirty="0"/>
           </a:p>
@@ -526,6 +527,94 @@
             <a:fld id="{F7021451-1387-4CA6-816F-3879F97B5CBC}" type="slidenum">
               <a:rPr lang="en-US"/>
               <a:t>1</a:t>
+            </a:fld>
+            <a:endParaRPr lang="en-US"/>
+          </a:p>
+        </p:txBody>
+      </p:sp>
+    </p:spTree>
+    <p:extLst>
+      <p:ext uri="{BB962C8B-B14F-4D97-AF65-F5344CB8AC3E}">
+        <p14:creationId xmlns:p14="http://schemas.microsoft.com/office/powerpoint/2010/main" val="1024086991"/>
+      </p:ext>
+    </p:extLst>
+  </p:cSld>
+  <p:clrMapOvr>
+    <a:masterClrMapping/>
+  </p:clrMapOvr>
+</p:notes>
+</file>
+
+<file path=ppt/notesSlides/notesSlide2.xml><?xml version="1.0" encoding="utf-8"?>
+<p:notes xmlns:a="http://schemas.openxmlformats.org/drawingml/2006/main" xmlns:r="http://schemas.openxmlformats.org/officeDocument/2006/relationships" xmlns:p="http://schemas.openxmlformats.org/presentationml/2006/main">
+  <p:cSld>
+    <p:spTree>
+      <p:nvGrpSpPr>
+        <p:cNvPr id="1" name=""/>
+        <p:cNvGrpSpPr/>
+        <p:nvPr/>
+      </p:nvGrpSpPr>
+      <p:grpSpPr>
+        <a:xfrm>
+          <a:off x="0" y="0"/>
+          <a:ext cx="0" cy="0"/>
+          <a:chOff x="0" y="0"/>
+          <a:chExt cx="0" cy="0"/>
+        </a:xfrm>
+      </p:grpSpPr>
+      <p:sp>
+        <p:nvSpPr>
+          <p:cNvPr id="2" name="Slide Image Placeholder 1"/>
+          <p:cNvSpPr>
+            <a:spLocks noGrp="1" noRot="1" noChangeAspect="1"/>
+          </p:cNvSpPr>
+          <p:nvPr>
+            <p:ph type="sldImg"/>
+          </p:nvPr>
+        </p:nvSpPr>
+        <p:spPr/>
+      </p:sp>
+      <p:sp>
+        <p:nvSpPr>
+          <p:cNvPr id="3" name="Notes Placeholder 2"/>
+          <p:cNvSpPr>
+            <a:spLocks noGrp="1"/>
+          </p:cNvSpPr>
+          <p:nvPr>
+            <p:ph type="body" idx="1"/>
+          </p:nvPr>
+        </p:nvSpPr>
+        <p:spPr/>
+        <p:txBody>
+          <a:bodyPr/>
+          <a:lstStyle/>
+          <a:p>
+            <a:r>
+              <a:rPr lang="en-US" dirty="0"/>
+              <a:t>Source : service Voirie (courriel du 12 octobre 2026). Montants TTC : 61 + 28 + 109 + 54 + 69 = 321 k€. Les interventions sont classées par ordre chronologique (le courriel ne les présente pas dans l’ordre). « Reprise des dalles » : reprise avec modification des plots d’assise. Zone 7 : magasins ATOL et OPHTALMED ; zone 62 : Foot Korner. Le calendrier des prochaines interventions n’est pas précisé.</a:t>
+            </a:r>
+            <a:endParaRPr lang="en-US" dirty="0"/>
+          </a:p>
+        </p:txBody>
+      </p:sp>
+      <p:sp>
+        <p:nvSpPr>
+          <p:cNvPr id="4" name="Slide Number Placeholder 3"/>
+          <p:cNvSpPr>
+            <a:spLocks noGrp="1"/>
+          </p:cNvSpPr>
+          <p:nvPr>
+            <p:ph type="sldNum" sz="quarter" idx="10"/>
+          </p:nvPr>
+        </p:nvSpPr>
+        <p:spPr/>
+        <p:txBody>
+          <a:bodyPr/>
+          <a:lstStyle/>
+          <a:p>
+            <a:fld id="{F7021451-1387-4CA6-816F-3879F97B5CBC}" type="slidenum">
+              <a:rPr lang="en-US"/>
+              <a:t>2</a:t>
             </a:fld>
             <a:endParaRPr lang="en-US"/>
           </a:p>
@@ -953,9 +1042,48 @@
           </a:p>
         </p:txBody>
       </p:sp>
+      <p:sp>
+        <p:nvSpPr>
+          <p:cNvPr id="4" name="Text 2"/>
+          <p:cNvSpPr txBox="1"/>
+          <p:nvPr/>
+        </p:nvSpPr>
+        <p:spPr>
+          <a:xfrm>
+            <a:off x="630936" y="1234440"/>
+            <a:ext cx="9144000" cy="365760"/>
+          </a:xfrm>
+          <a:prstGeom prst="rect">
+            <a:avLst/>
+          </a:prstGeom>
+          <a:noFill/>
+          <a:ln/>
+        </p:spPr>
+        <p:txBody>
+          <a:bodyPr wrap="square" lIns="0" tIns="0" rIns="0" bIns="0" rtlCol="0" anchor="ctr"/>
+          <a:lstStyle/>
+          <a:p>
+            <a:pPr indent="0" marL="0">
+              <a:buNone/>
+            </a:pPr>
+            <a:r>
+              <a:rPr lang="en-US" sz="1400" dirty="0">
+                <a:solidFill>
+                  <a:srgbClr val="FFFFFF"/>
+                </a:solidFill>
+                <a:latin typeface="Arial" pitchFamily="34" charset="0"/>
+                <a:ea typeface="Arial" pitchFamily="34" charset="-122"/>
+                <a:cs typeface="Arial" pitchFamily="34" charset="-120"/>
+              </a:rPr>
+              <a:t>Une dalle des années 1970, construite au-dessus du centre commercial et de la gare RER</a:t>
+            </a:r>
+            <a:endParaRPr lang="en-US" sz="1400" dirty="0"/>
+          </a:p>
+        </p:txBody>
+      </p:sp>
       <p:pic>
         <p:nvPicPr>
-          <p:cNvPr id="4" name="Image 0" descr="/tmp/claude-0/-home-user-Operation-robespierre/996c8343-2b29-5be8-89e5-6b613d278f5f/scratchpad/logo_rp_x3.png">    </p:cNvPr>
+          <p:cNvPr id="5" name="Image 0" descr="/tmp/claude-0/-home-user-Operation-robespierre/996c8343-2b29-5be8-89e5-6b613d278f5f/scratchpad/logo_rp_x3.png">    </p:cNvPr>
           <p:cNvPicPr>
             <a:picLocks noChangeAspect="1"/>
           </p:cNvPicPr>
@@ -979,7 +1107,7 @@
       </p:pic>
       <p:pic>
         <p:nvPicPr>
-          <p:cNvPr id="5" name="vue_aerienne" descr="/home/user/Operation_robespierre/reunion_varenne_2026-10-08/dalle_gustave_courbet_bandeau.png">    </p:cNvPr>
+          <p:cNvPr id="6" name="Image 1" descr="/home/user/Operation_robespierre/reunion_varenne_2026-10-08/dalle_gustave_courbet_colonne.png">    </p:cNvPr>
           <p:cNvPicPr>
             <a:picLocks noChangeAspect="1"/>
           </p:cNvPicPr>
@@ -993,8 +1121,8 @@
         </p:blipFill>
         <p:spPr>
           <a:xfrm>
-            <a:off x="630936" y="1600200"/>
-            <a:ext cx="10927080" cy="4837509"/>
+            <a:off x="630936" y="1783080"/>
+            <a:ext cx="6675120" cy="4531650"/>
           </a:xfrm>
           <a:prstGeom prst="rect">
             <a:avLst/>
@@ -1003,13 +1131,13 @@
       </p:pic>
       <p:sp>
         <p:nvSpPr>
-          <p:cNvPr id="6" name="Text 2"/>
-          <p:cNvSpPr txBox="1"/>
-          <p:nvPr/>
-        </p:nvSpPr>
-        <p:spPr>
-          <a:xfrm>
-            <a:off x="9454896" y="6053661"/>
+          <p:cNvPr id="7" name="Text 3"/>
+          <p:cNvSpPr txBox="1"/>
+          <p:nvPr/>
+        </p:nvSpPr>
+        <p:spPr>
+          <a:xfrm>
+            <a:off x="5202936" y="5948970"/>
             <a:ext cx="1965960" cy="274320"/>
           </a:xfrm>
           <a:prstGeom prst="rect">
@@ -1037,6 +1165,1439 @@
               <a:t>© IGN – BD ORTHO</a:t>
             </a:r>
             <a:endParaRPr lang="en-US" sz="1100" dirty="0"/>
+          </a:p>
+        </p:txBody>
+      </p:sp>
+      <p:sp>
+        <p:nvSpPr>
+          <p:cNvPr id="8" name="Shape 4"/>
+          <p:cNvSpPr/>
+          <p:nvPr/>
+        </p:nvSpPr>
+        <p:spPr>
+          <a:xfrm>
+            <a:off x="7635240" y="1783080"/>
+            <a:ext cx="3931920" cy="0"/>
+          </a:xfrm>
+          <a:prstGeom prst="line">
+            <a:avLst/>
+          </a:prstGeom>
+          <a:noFill/>
+          <a:ln w="31750">
+            <a:solidFill>
+              <a:srgbClr val="72C493"/>
+            </a:solidFill>
+            <a:prstDash val="solid"/>
+          </a:ln>
+        </p:spPr>
+      </p:sp>
+      <p:sp>
+        <p:nvSpPr>
+          <p:cNvPr id="9" name="Text 5"/>
+          <p:cNvSpPr txBox="1"/>
+          <p:nvPr/>
+        </p:nvSpPr>
+        <p:spPr>
+          <a:xfrm>
+            <a:off x="7635240" y="1920240"/>
+            <a:ext cx="3931920" cy="320040"/>
+          </a:xfrm>
+          <a:prstGeom prst="rect">
+            <a:avLst/>
+          </a:prstGeom>
+          <a:noFill/>
+          <a:ln/>
+        </p:spPr>
+        <p:txBody>
+          <a:bodyPr wrap="square" lIns="0" tIns="0" rIns="0" bIns="0" rtlCol="0" anchor="ctr"/>
+          <a:lstStyle/>
+          <a:p>
+            <a:pPr indent="0" marL="0">
+              <a:buNone/>
+            </a:pPr>
+            <a:r>
+              <a:rPr lang="en-US" sz="1400" b="1" spc="200" kern="0" dirty="0">
+                <a:solidFill>
+                  <a:srgbClr val="72C493"/>
+                </a:solidFill>
+                <a:latin typeface="Arial" pitchFamily="34" charset="0"/>
+                <a:ea typeface="Arial" pitchFamily="34" charset="-122"/>
+                <a:cs typeface="Arial" pitchFamily="34" charset="-120"/>
+              </a:rPr>
+              <a:t>CE QUI POSE PROBLÈME</a:t>
+            </a:r>
+            <a:endParaRPr lang="en-US" sz="1400" dirty="0"/>
+          </a:p>
+        </p:txBody>
+      </p:sp>
+      <p:sp>
+        <p:nvSpPr>
+          <p:cNvPr id="10" name="Text 6"/>
+          <p:cNvSpPr txBox="1"/>
+          <p:nvPr/>
+        </p:nvSpPr>
+        <p:spPr>
+          <a:xfrm>
+            <a:off x="7635240" y="2377440"/>
+            <a:ext cx="3931920" cy="1700784"/>
+          </a:xfrm>
+          <a:prstGeom prst="rect">
+            <a:avLst/>
+          </a:prstGeom>
+          <a:noFill/>
+          <a:ln/>
+        </p:spPr>
+        <p:txBody>
+          <a:bodyPr wrap="square" lIns="0" tIns="0" rIns="0" bIns="0" rtlCol="0" anchor="t"/>
+          <a:lstStyle/>
+          <a:p>
+            <a:pPr marL="203200" indent="-203200">
+              <a:spcAft>
+                <a:spcPts val="800"/>
+              </a:spcAft>
+              <a:buSzPct val="100000"/>
+              <a:buChar char="•"/>
+            </a:pPr>
+            <a:r>
+              <a:rPr lang="en-US" sz="1500" dirty="0">
+                <a:solidFill>
+                  <a:srgbClr val="FFFFFF"/>
+                </a:solidFill>
+                <a:latin typeface="Arial" pitchFamily="34" charset="0"/>
+                <a:ea typeface="Arial" pitchFamily="34" charset="-122"/>
+                <a:cs typeface="Arial" pitchFamily="34" charset="-120"/>
+              </a:rPr>
+              <a:t>Des dalles qui basculent sous les pas</a:t>
+            </a:r>
+            <a:endParaRPr lang="en-US" sz="1500" dirty="0"/>
+          </a:p>
+          <a:p>
+            <a:pPr marL="203200" indent="-203200">
+              <a:spcAft>
+                <a:spcPts val="800"/>
+              </a:spcAft>
+              <a:buSzPct val="100000"/>
+              <a:buChar char="•"/>
+            </a:pPr>
+            <a:r>
+              <a:rPr lang="en-US" sz="1500" dirty="0">
+                <a:solidFill>
+                  <a:srgbClr val="FFFFFF"/>
+                </a:solidFill>
+                <a:latin typeface="Arial" pitchFamily="34" charset="0"/>
+                <a:ea typeface="Arial" pitchFamily="34" charset="-122"/>
+                <a:cs typeface="Arial" pitchFamily="34" charset="-120"/>
+              </a:rPr>
+              <a:t>Des infiltrations d’eau dans les commerces du centre commercial</a:t>
+            </a:r>
+            <a:endParaRPr lang="en-US" sz="1500" dirty="0"/>
+          </a:p>
+          <a:p>
+            <a:pPr marL="203200" indent="-203200">
+              <a:spcAft>
+                <a:spcPts val="800"/>
+              </a:spcAft>
+              <a:buSzPct val="100000"/>
+              <a:buChar char="•"/>
+            </a:pPr>
+            <a:r>
+              <a:rPr lang="en-US" sz="1500" dirty="0">
+                <a:solidFill>
+                  <a:srgbClr val="FFFFFF"/>
+                </a:solidFill>
+                <a:latin typeface="Arial" pitchFamily="34" charset="0"/>
+                <a:ea typeface="Arial" pitchFamily="34" charset="-122"/>
+                <a:cs typeface="Arial" pitchFamily="34" charset="-120"/>
+              </a:rPr>
+              <a:t>Des défauts sur l’éclairage public</a:t>
+            </a:r>
+            <a:endParaRPr lang="en-US" sz="1500" dirty="0"/>
+          </a:p>
+        </p:txBody>
+      </p:sp>
+      <p:sp>
+        <p:nvSpPr>
+          <p:cNvPr id="11" name="Shape 7"/>
+          <p:cNvSpPr/>
+          <p:nvPr/>
+        </p:nvSpPr>
+        <p:spPr>
+          <a:xfrm>
+            <a:off x="7635240" y="4297680"/>
+            <a:ext cx="3931920" cy="0"/>
+          </a:xfrm>
+          <a:prstGeom prst="line">
+            <a:avLst/>
+          </a:prstGeom>
+          <a:noFill/>
+          <a:ln w="31750">
+            <a:solidFill>
+              <a:srgbClr val="72C493"/>
+            </a:solidFill>
+            <a:prstDash val="solid"/>
+          </a:ln>
+        </p:spPr>
+      </p:sp>
+      <p:sp>
+        <p:nvSpPr>
+          <p:cNvPr id="12" name="Text 8"/>
+          <p:cNvSpPr txBox="1"/>
+          <p:nvPr/>
+        </p:nvSpPr>
+        <p:spPr>
+          <a:xfrm>
+            <a:off x="7635240" y="4434840"/>
+            <a:ext cx="3931920" cy="320040"/>
+          </a:xfrm>
+          <a:prstGeom prst="rect">
+            <a:avLst/>
+          </a:prstGeom>
+          <a:noFill/>
+          <a:ln/>
+        </p:spPr>
+        <p:txBody>
+          <a:bodyPr wrap="square" lIns="0" tIns="0" rIns="0" bIns="0" rtlCol="0" anchor="ctr"/>
+          <a:lstStyle/>
+          <a:p>
+            <a:pPr indent="0" marL="0">
+              <a:buNone/>
+            </a:pPr>
+            <a:r>
+              <a:rPr lang="en-US" sz="1400" b="1" spc="200" kern="0" dirty="0">
+                <a:solidFill>
+                  <a:srgbClr val="72C493"/>
+                </a:solidFill>
+                <a:latin typeface="Arial" pitchFamily="34" charset="0"/>
+                <a:ea typeface="Arial" pitchFamily="34" charset="-122"/>
+                <a:cs typeface="Arial" pitchFamily="34" charset="-120"/>
+              </a:rPr>
+              <a:t>CE QUI EST PRÉVU</a:t>
+            </a:r>
+            <a:endParaRPr lang="en-US" sz="1400" dirty="0"/>
+          </a:p>
+        </p:txBody>
+      </p:sp>
+      <p:sp>
+        <p:nvSpPr>
+          <p:cNvPr id="13" name="Text 9"/>
+          <p:cNvSpPr txBox="1"/>
+          <p:nvPr/>
+        </p:nvSpPr>
+        <p:spPr>
+          <a:xfrm>
+            <a:off x="7635240" y="4892040"/>
+            <a:ext cx="3931920" cy="1133856"/>
+          </a:xfrm>
+          <a:prstGeom prst="rect">
+            <a:avLst/>
+          </a:prstGeom>
+          <a:noFill/>
+          <a:ln/>
+        </p:spPr>
+        <p:txBody>
+          <a:bodyPr wrap="square" lIns="0" tIns="0" rIns="0" bIns="0" rtlCol="0" anchor="t"/>
+          <a:lstStyle/>
+          <a:p>
+            <a:pPr marL="203200" indent="-203200">
+              <a:spcAft>
+                <a:spcPts val="800"/>
+              </a:spcAft>
+              <a:buSzPct val="100000"/>
+              <a:buChar char="•"/>
+            </a:pPr>
+            <a:r>
+              <a:rPr lang="en-US" sz="1500" dirty="0">
+                <a:solidFill>
+                  <a:srgbClr val="FFFFFF"/>
+                </a:solidFill>
+                <a:latin typeface="Arial" pitchFamily="34" charset="0"/>
+                <a:ea typeface="Arial" pitchFamily="34" charset="-122"/>
+                <a:cs typeface="Arial" pitchFamily="34" charset="-120"/>
+              </a:rPr>
+              <a:t>Remplacement progressif des dalles par des lames composites</a:t>
+            </a:r>
+            <a:endParaRPr lang="en-US" sz="1500" dirty="0"/>
+          </a:p>
+          <a:p>
+            <a:pPr marL="203200" indent="-203200">
+              <a:spcAft>
+                <a:spcPts val="800"/>
+              </a:spcAft>
+              <a:buSzPct val="100000"/>
+              <a:buChar char="•"/>
+            </a:pPr>
+            <a:r>
+              <a:rPr lang="en-US" sz="1500" dirty="0">
+                <a:solidFill>
+                  <a:srgbClr val="FFFFFF"/>
+                </a:solidFill>
+                <a:latin typeface="Arial" pitchFamily="34" charset="0"/>
+                <a:ea typeface="Arial" pitchFamily="34" charset="-122"/>
+                <a:cs typeface="Arial" pitchFamily="34" charset="-120"/>
+              </a:rPr>
+              <a:t>Pose de fourreaux pour un futur réseau de caméras</a:t>
+            </a:r>
+            <a:endParaRPr lang="en-US" sz="1500" dirty="0"/>
+          </a:p>
+        </p:txBody>
+      </p:sp>
+    </p:spTree>
+  </p:cSld>
+  <p:clrMapOvr>
+    <a:masterClrMapping/>
+  </p:clrMapOvr>
+</p:sld>
+</file>
+
+<file path=ppt/slides/slide2.xml><?xml version="1.0" encoding="utf-8"?>
+<p:sld xmlns:a="http://schemas.openxmlformats.org/drawingml/2006/main" xmlns:r="http://schemas.openxmlformats.org/officeDocument/2006/relationships" xmlns:p="http://schemas.openxmlformats.org/presentationml/2006/main">
+  <p:cSld name="Slide 2">
+    <p:bg>
+      <p:bgPr>
+        <a:solidFill>
+          <a:srgbClr val="0E1F5B"/>
+        </a:solidFill>
+      </p:bgPr>
+    </p:bg>
+    <p:spTree>
+      <p:nvGrpSpPr>
+        <p:cNvPr id="1" name=""/>
+        <p:cNvGrpSpPr/>
+        <p:nvPr/>
+      </p:nvGrpSpPr>
+      <p:grpSpPr>
+        <a:xfrm>
+          <a:off x="0" y="0"/>
+          <a:ext cx="0" cy="0"/>
+          <a:chOff x="0" y="0"/>
+          <a:chExt cx="0" cy="0"/>
+        </a:xfrm>
+      </p:grpSpPr>
+      <p:sp>
+        <p:nvSpPr>
+          <p:cNvPr id="2" name="Text 0"/>
+          <p:cNvSpPr txBox="1"/>
+          <p:nvPr/>
+        </p:nvSpPr>
+        <p:spPr>
+          <a:xfrm>
+            <a:off x="630936" y="292608"/>
+            <a:ext cx="8229600" cy="320040"/>
+          </a:xfrm>
+          <a:prstGeom prst="rect">
+            <a:avLst/>
+          </a:prstGeom>
+          <a:noFill/>
+          <a:ln/>
+        </p:spPr>
+        <p:txBody>
+          <a:bodyPr wrap="square" lIns="0" tIns="0" rIns="0" bIns="0" rtlCol="0" anchor="ctr"/>
+          <a:lstStyle/>
+          <a:p>
+            <a:pPr indent="0" marL="0">
+              <a:buNone/>
+            </a:pPr>
+            <a:r>
+              <a:rPr lang="en-US" sz="1300" b="1" spc="200" kern="0" dirty="0">
+                <a:solidFill>
+                  <a:srgbClr val="72C493"/>
+                </a:solidFill>
+                <a:latin typeface="Arial" pitchFamily="34" charset="0"/>
+                <a:ea typeface="Arial" pitchFamily="34" charset="-122"/>
+                <a:cs typeface="Arial" pitchFamily="34" charset="-120"/>
+              </a:rPr>
+              <a:t>01 — AMÉNAGEMENT URBAIN</a:t>
+            </a:r>
+            <a:endParaRPr lang="en-US" sz="1300" dirty="0"/>
+          </a:p>
+        </p:txBody>
+      </p:sp>
+      <p:sp>
+        <p:nvSpPr>
+          <p:cNvPr id="3" name="Text 1"/>
+          <p:cNvSpPr txBox="1"/>
+          <p:nvPr/>
+        </p:nvSpPr>
+        <p:spPr>
+          <a:xfrm>
+            <a:off x="630936" y="640080"/>
+            <a:ext cx="9144000" cy="594360"/>
+          </a:xfrm>
+          <a:prstGeom prst="rect">
+            <a:avLst/>
+          </a:prstGeom>
+          <a:noFill/>
+          <a:ln/>
+        </p:spPr>
+        <p:txBody>
+          <a:bodyPr wrap="square" lIns="0" tIns="0" rIns="0" bIns="0" rtlCol="0" anchor="ctr"/>
+          <a:lstStyle/>
+          <a:p>
+            <a:pPr indent="0" marL="0">
+              <a:buNone/>
+            </a:pPr>
+            <a:r>
+              <a:rPr lang="en-US" sz="2700" b="1" dirty="0">
+                <a:solidFill>
+                  <a:srgbClr val="FFFFFF"/>
+                </a:solidFill>
+                <a:latin typeface="Arial" pitchFamily="34" charset="0"/>
+                <a:ea typeface="Arial" pitchFamily="34" charset="-122"/>
+                <a:cs typeface="Arial" pitchFamily="34" charset="-120"/>
+              </a:rPr>
+              <a:t>La dalle de la place Gustave-Courbet</a:t>
+            </a:r>
+            <a:endParaRPr lang="en-US" sz="2700" dirty="0"/>
+          </a:p>
+        </p:txBody>
+      </p:sp>
+      <p:sp>
+        <p:nvSpPr>
+          <p:cNvPr id="4" name="Text 2"/>
+          <p:cNvSpPr txBox="1"/>
+          <p:nvPr/>
+        </p:nvSpPr>
+        <p:spPr>
+          <a:xfrm>
+            <a:off x="630936" y="1234440"/>
+            <a:ext cx="9144000" cy="365760"/>
+          </a:xfrm>
+          <a:prstGeom prst="rect">
+            <a:avLst/>
+          </a:prstGeom>
+          <a:noFill/>
+          <a:ln/>
+        </p:spPr>
+        <p:txBody>
+          <a:bodyPr wrap="square" lIns="0" tIns="0" rIns="0" bIns="0" rtlCol="0" anchor="ctr"/>
+          <a:lstStyle/>
+          <a:p>
+            <a:pPr indent="0" marL="0">
+              <a:buNone/>
+            </a:pPr>
+            <a:r>
+              <a:rPr lang="en-US" sz="1400" dirty="0">
+                <a:solidFill>
+                  <a:srgbClr val="FFFFFF"/>
+                </a:solidFill>
+                <a:latin typeface="Arial" pitchFamily="34" charset="0"/>
+                <a:ea typeface="Arial" pitchFamily="34" charset="-122"/>
+                <a:cs typeface="Arial" pitchFamily="34" charset="-120"/>
+              </a:rPr>
+              <a:t>Les travaux engagés par la Ville</a:t>
+            </a:r>
+            <a:endParaRPr lang="en-US" sz="1400" dirty="0"/>
+          </a:p>
+        </p:txBody>
+      </p:sp>
+      <p:pic>
+        <p:nvPicPr>
+          <p:cNvPr id="5" name="Image 0" descr="/tmp/claude-0/-home-user-Operation-robespierre/996c8343-2b29-5be8-89e5-6b613d278f5f/scratchpad/logo_rp_x3.png">    </p:cNvPr>
+          <p:cNvPicPr>
+            <a:picLocks noChangeAspect="1"/>
+          </p:cNvPicPr>
+          <p:nvPr/>
+        </p:nvPicPr>
+        <p:blipFill>
+          <a:blip r:embed="rId1"/>
+          <a:stretch>
+            <a:fillRect/>
+          </a:stretch>
+        </p:blipFill>
+        <p:spPr>
+          <a:xfrm>
+            <a:off x="10607040" y="137160"/>
+            <a:ext cx="1216152" cy="1298448"/>
+          </a:xfrm>
+          <a:prstGeom prst="rect">
+            <a:avLst/>
+          </a:prstGeom>
+        </p:spPr>
+      </p:pic>
+      <p:sp>
+        <p:nvSpPr>
+          <p:cNvPr id="6" name="Text 3"/>
+          <p:cNvSpPr txBox="1"/>
+          <p:nvPr/>
+        </p:nvSpPr>
+        <p:spPr>
+          <a:xfrm>
+            <a:off x="630936" y="1828800"/>
+            <a:ext cx="4572000" cy="914400"/>
+          </a:xfrm>
+          <a:prstGeom prst="rect">
+            <a:avLst/>
+          </a:prstGeom>
+          <a:noFill/>
+          <a:ln/>
+        </p:spPr>
+        <p:txBody>
+          <a:bodyPr wrap="square" lIns="0" tIns="0" rIns="0" bIns="0" rtlCol="0" anchor="ctr"/>
+          <a:lstStyle/>
+          <a:p>
+            <a:pPr indent="0" marL="0">
+              <a:buNone/>
+            </a:pPr>
+            <a:r>
+              <a:rPr lang="en-US" sz="6000" b="1" dirty="0">
+                <a:solidFill>
+                  <a:srgbClr val="72C493"/>
+                </a:solidFill>
+                <a:latin typeface="Arial" pitchFamily="34" charset="0"/>
+                <a:ea typeface="Arial" pitchFamily="34" charset="-122"/>
+                <a:cs typeface="Arial" pitchFamily="34" charset="-120"/>
+              </a:rPr>
+              <a:t>321 000 €</a:t>
+            </a:r>
+            <a:endParaRPr lang="en-US" sz="6000" dirty="0"/>
+          </a:p>
+        </p:txBody>
+      </p:sp>
+      <p:sp>
+        <p:nvSpPr>
+          <p:cNvPr id="7" name="Text 4"/>
+          <p:cNvSpPr txBox="1"/>
+          <p:nvPr/>
+        </p:nvSpPr>
+        <p:spPr>
+          <a:xfrm>
+            <a:off x="630936" y="2743200"/>
+            <a:ext cx="4754880" cy="640080"/>
+          </a:xfrm>
+          <a:prstGeom prst="rect">
+            <a:avLst/>
+          </a:prstGeom>
+          <a:noFill/>
+          <a:ln/>
+        </p:spPr>
+        <p:txBody>
+          <a:bodyPr wrap="square" lIns="0" tIns="0" rIns="0" bIns="0" rtlCol="0" anchor="t"/>
+          <a:lstStyle/>
+          <a:p>
+            <a:pPr indent="0" marL="0">
+              <a:buNone/>
+            </a:pPr>
+            <a:r>
+              <a:rPr lang="en-US" sz="1600" b="1" dirty="0">
+                <a:solidFill>
+                  <a:srgbClr val="FFFFFF"/>
+                </a:solidFill>
+                <a:latin typeface="Arial" pitchFamily="34" charset="0"/>
+                <a:ea typeface="Arial" pitchFamily="34" charset="-122"/>
+                <a:cs typeface="Arial" pitchFamily="34" charset="-120"/>
+              </a:rPr>
+              <a:t>investis en 2025 pour réparer la dalle, en 5 interventions</a:t>
+            </a:r>
+            <a:endParaRPr lang="en-US" sz="1600" dirty="0"/>
+          </a:p>
+        </p:txBody>
+      </p:sp>
+      <p:sp>
+        <p:nvSpPr>
+          <p:cNvPr id="8" name="Shape 5"/>
+          <p:cNvSpPr/>
+          <p:nvPr/>
+        </p:nvSpPr>
+        <p:spPr>
+          <a:xfrm>
+            <a:off x="5852160" y="1783080"/>
+            <a:ext cx="5715000" cy="0"/>
+          </a:xfrm>
+          <a:prstGeom prst="line">
+            <a:avLst/>
+          </a:prstGeom>
+          <a:noFill/>
+          <a:ln w="31750">
+            <a:solidFill>
+              <a:srgbClr val="72C493"/>
+            </a:solidFill>
+            <a:prstDash val="solid"/>
+          </a:ln>
+        </p:spPr>
+      </p:sp>
+      <p:sp>
+        <p:nvSpPr>
+          <p:cNvPr id="9" name="Text 6"/>
+          <p:cNvSpPr txBox="1"/>
+          <p:nvPr/>
+        </p:nvSpPr>
+        <p:spPr>
+          <a:xfrm>
+            <a:off x="5852160" y="1920240"/>
+            <a:ext cx="5715000" cy="320040"/>
+          </a:xfrm>
+          <a:prstGeom prst="rect">
+            <a:avLst/>
+          </a:prstGeom>
+          <a:noFill/>
+          <a:ln/>
+        </p:spPr>
+        <p:txBody>
+          <a:bodyPr wrap="square" lIns="0" tIns="0" rIns="0" bIns="0" rtlCol="0" anchor="ctr"/>
+          <a:lstStyle/>
+          <a:p>
+            <a:pPr indent="0" marL="0">
+              <a:buNone/>
+            </a:pPr>
+            <a:r>
+              <a:rPr lang="en-US" sz="1400" b="1" spc="200" kern="0" dirty="0">
+                <a:solidFill>
+                  <a:srgbClr val="72C493"/>
+                </a:solidFill>
+                <a:latin typeface="Arial" pitchFamily="34" charset="0"/>
+                <a:ea typeface="Arial" pitchFamily="34" charset="-122"/>
+                <a:cs typeface="Arial" pitchFamily="34" charset="-120"/>
+              </a:rPr>
+              <a:t>LES INTERVENTIONS DE 2025</a:t>
+            </a:r>
+            <a:endParaRPr lang="en-US" sz="1400" dirty="0"/>
+          </a:p>
+        </p:txBody>
+      </p:sp>
+      <p:sp>
+        <p:nvSpPr>
+          <p:cNvPr id="10" name="Text 7"/>
+          <p:cNvSpPr txBox="1"/>
+          <p:nvPr/>
+        </p:nvSpPr>
+        <p:spPr>
+          <a:xfrm>
+            <a:off x="5852160" y="2377440"/>
+            <a:ext cx="1325880" cy="411480"/>
+          </a:xfrm>
+          <a:prstGeom prst="rect">
+            <a:avLst/>
+          </a:prstGeom>
+          <a:noFill/>
+          <a:ln/>
+        </p:spPr>
+        <p:txBody>
+          <a:bodyPr wrap="square" lIns="0" tIns="0" rIns="0" bIns="0" rtlCol="0" anchor="ctr"/>
+          <a:lstStyle/>
+          <a:p>
+            <a:pPr indent="0" marL="0">
+              <a:buNone/>
+            </a:pPr>
+            <a:r>
+              <a:rPr lang="en-US" sz="1400" b="1" dirty="0">
+                <a:solidFill>
+                  <a:srgbClr val="FFFFFF"/>
+                </a:solidFill>
+                <a:latin typeface="Arial" pitchFamily="34" charset="0"/>
+                <a:ea typeface="Arial" pitchFamily="34" charset="-122"/>
+                <a:cs typeface="Arial" pitchFamily="34" charset="-120"/>
+              </a:rPr>
+              <a:t>Janv. – févr.</a:t>
+            </a:r>
+            <a:endParaRPr lang="en-US" sz="1400" dirty="0"/>
+          </a:p>
+        </p:txBody>
+      </p:sp>
+      <p:sp>
+        <p:nvSpPr>
+          <p:cNvPr id="11" name="Text 8"/>
+          <p:cNvSpPr txBox="1"/>
+          <p:nvPr/>
+        </p:nvSpPr>
+        <p:spPr>
+          <a:xfrm>
+            <a:off x="7223760" y="2377440"/>
+            <a:ext cx="1828800" cy="411480"/>
+          </a:xfrm>
+          <a:prstGeom prst="rect">
+            <a:avLst/>
+          </a:prstGeom>
+          <a:noFill/>
+          <a:ln/>
+        </p:spPr>
+        <p:txBody>
+          <a:bodyPr wrap="square" lIns="0" tIns="0" rIns="0" bIns="0" rtlCol="0" anchor="ctr"/>
+          <a:lstStyle/>
+          <a:p>
+            <a:pPr indent="0" marL="0">
+              <a:buNone/>
+            </a:pPr>
+            <a:r>
+              <a:rPr lang="en-US" sz="1400" dirty="0">
+                <a:solidFill>
+                  <a:srgbClr val="FFFFFF"/>
+                </a:solidFill>
+                <a:latin typeface="Arial" pitchFamily="34" charset="0"/>
+                <a:ea typeface="Arial" pitchFamily="34" charset="-122"/>
+                <a:cs typeface="Arial" pitchFamily="34" charset="-120"/>
+              </a:rPr>
+              <a:t>Lames composites</a:t>
+            </a:r>
+            <a:endParaRPr lang="en-US" sz="1400" dirty="0"/>
+          </a:p>
+        </p:txBody>
+      </p:sp>
+      <p:sp>
+        <p:nvSpPr>
+          <p:cNvPr id="12" name="Shape 9"/>
+          <p:cNvSpPr/>
+          <p:nvPr/>
+        </p:nvSpPr>
+        <p:spPr>
+          <a:xfrm>
+            <a:off x="9098280" y="2468880"/>
+            <a:ext cx="793179" cy="228600"/>
+          </a:xfrm>
+          <a:prstGeom prst="rect">
+            <a:avLst/>
+          </a:prstGeom>
+          <a:solidFill>
+            <a:srgbClr val="72C493"/>
+          </a:solidFill>
+          <a:ln/>
+        </p:spPr>
+      </p:sp>
+      <p:sp>
+        <p:nvSpPr>
+          <p:cNvPr id="13" name="Text 10"/>
+          <p:cNvSpPr txBox="1"/>
+          <p:nvPr/>
+        </p:nvSpPr>
+        <p:spPr>
+          <a:xfrm>
+            <a:off x="9982899" y="2377440"/>
+            <a:ext cx="1097280" cy="411480"/>
+          </a:xfrm>
+          <a:prstGeom prst="rect">
+            <a:avLst/>
+          </a:prstGeom>
+          <a:noFill/>
+          <a:ln/>
+        </p:spPr>
+        <p:txBody>
+          <a:bodyPr wrap="square" lIns="0" tIns="0" rIns="0" bIns="0" rtlCol="0" anchor="ctr"/>
+          <a:lstStyle/>
+          <a:p>
+            <a:pPr indent="0" marL="0">
+              <a:buNone/>
+            </a:pPr>
+            <a:r>
+              <a:rPr lang="en-US" sz="1400" b="1" dirty="0">
+                <a:solidFill>
+                  <a:srgbClr val="FFFFFF"/>
+                </a:solidFill>
+                <a:latin typeface="Arial" pitchFamily="34" charset="0"/>
+                <a:ea typeface="Arial" pitchFamily="34" charset="-122"/>
+                <a:cs typeface="Arial" pitchFamily="34" charset="-120"/>
+              </a:rPr>
+              <a:t>61 000 €</a:t>
+            </a:r>
+            <a:endParaRPr lang="en-US" sz="1400" dirty="0"/>
+          </a:p>
+        </p:txBody>
+      </p:sp>
+      <p:sp>
+        <p:nvSpPr>
+          <p:cNvPr id="14" name="Text 11"/>
+          <p:cNvSpPr txBox="1"/>
+          <p:nvPr/>
+        </p:nvSpPr>
+        <p:spPr>
+          <a:xfrm>
+            <a:off x="5852160" y="2944368"/>
+            <a:ext cx="1325880" cy="411480"/>
+          </a:xfrm>
+          <a:prstGeom prst="rect">
+            <a:avLst/>
+          </a:prstGeom>
+          <a:noFill/>
+          <a:ln/>
+        </p:spPr>
+        <p:txBody>
+          <a:bodyPr wrap="square" lIns="0" tIns="0" rIns="0" bIns="0" rtlCol="0" anchor="ctr"/>
+          <a:lstStyle/>
+          <a:p>
+            <a:pPr indent="0" marL="0">
+              <a:buNone/>
+            </a:pPr>
+            <a:r>
+              <a:rPr lang="en-US" sz="1400" b="1" dirty="0">
+                <a:solidFill>
+                  <a:srgbClr val="FFFFFF"/>
+                </a:solidFill>
+                <a:latin typeface="Arial" pitchFamily="34" charset="0"/>
+                <a:ea typeface="Arial" pitchFamily="34" charset="-122"/>
+                <a:cs typeface="Arial" pitchFamily="34" charset="-120"/>
+              </a:rPr>
+              <a:t>Mars – avril</a:t>
+            </a:r>
+            <a:endParaRPr lang="en-US" sz="1400" dirty="0"/>
+          </a:p>
+        </p:txBody>
+      </p:sp>
+      <p:sp>
+        <p:nvSpPr>
+          <p:cNvPr id="15" name="Text 12"/>
+          <p:cNvSpPr txBox="1"/>
+          <p:nvPr/>
+        </p:nvSpPr>
+        <p:spPr>
+          <a:xfrm>
+            <a:off x="7223760" y="2944368"/>
+            <a:ext cx="1828800" cy="411480"/>
+          </a:xfrm>
+          <a:prstGeom prst="rect">
+            <a:avLst/>
+          </a:prstGeom>
+          <a:noFill/>
+          <a:ln/>
+        </p:spPr>
+        <p:txBody>
+          <a:bodyPr wrap="square" lIns="0" tIns="0" rIns="0" bIns="0" rtlCol="0" anchor="ctr"/>
+          <a:lstStyle/>
+          <a:p>
+            <a:pPr indent="0" marL="0">
+              <a:buNone/>
+            </a:pPr>
+            <a:r>
+              <a:rPr lang="en-US" sz="1400" dirty="0">
+                <a:solidFill>
+                  <a:srgbClr val="FFFFFF"/>
+                </a:solidFill>
+                <a:latin typeface="Arial" pitchFamily="34" charset="0"/>
+                <a:ea typeface="Arial" pitchFamily="34" charset="-122"/>
+                <a:cs typeface="Arial" pitchFamily="34" charset="-120"/>
+              </a:rPr>
+              <a:t>Reprise des dalles</a:t>
+            </a:r>
+            <a:endParaRPr lang="en-US" sz="1400" dirty="0"/>
+          </a:p>
+        </p:txBody>
+      </p:sp>
+      <p:sp>
+        <p:nvSpPr>
+          <p:cNvPr id="16" name="Shape 13"/>
+          <p:cNvSpPr/>
+          <p:nvPr/>
+        </p:nvSpPr>
+        <p:spPr>
+          <a:xfrm>
+            <a:off x="9098280" y="3035808"/>
+            <a:ext cx="364082" cy="228600"/>
+          </a:xfrm>
+          <a:prstGeom prst="rect">
+            <a:avLst/>
+          </a:prstGeom>
+          <a:solidFill>
+            <a:srgbClr val="72C493"/>
+          </a:solidFill>
+          <a:ln/>
+        </p:spPr>
+      </p:sp>
+      <p:sp>
+        <p:nvSpPr>
+          <p:cNvPr id="17" name="Text 14"/>
+          <p:cNvSpPr txBox="1"/>
+          <p:nvPr/>
+        </p:nvSpPr>
+        <p:spPr>
+          <a:xfrm>
+            <a:off x="9553802" y="2944368"/>
+            <a:ext cx="1097280" cy="411480"/>
+          </a:xfrm>
+          <a:prstGeom prst="rect">
+            <a:avLst/>
+          </a:prstGeom>
+          <a:noFill/>
+          <a:ln/>
+        </p:spPr>
+        <p:txBody>
+          <a:bodyPr wrap="square" lIns="0" tIns="0" rIns="0" bIns="0" rtlCol="0" anchor="ctr"/>
+          <a:lstStyle/>
+          <a:p>
+            <a:pPr indent="0" marL="0">
+              <a:buNone/>
+            </a:pPr>
+            <a:r>
+              <a:rPr lang="en-US" sz="1400" b="1" dirty="0">
+                <a:solidFill>
+                  <a:srgbClr val="FFFFFF"/>
+                </a:solidFill>
+                <a:latin typeface="Arial" pitchFamily="34" charset="0"/>
+                <a:ea typeface="Arial" pitchFamily="34" charset="-122"/>
+                <a:cs typeface="Arial" pitchFamily="34" charset="-120"/>
+              </a:rPr>
+              <a:t>28 000 €</a:t>
+            </a:r>
+            <a:endParaRPr lang="en-US" sz="1400" dirty="0"/>
+          </a:p>
+        </p:txBody>
+      </p:sp>
+      <p:sp>
+        <p:nvSpPr>
+          <p:cNvPr id="18" name="Text 15"/>
+          <p:cNvSpPr txBox="1"/>
+          <p:nvPr/>
+        </p:nvSpPr>
+        <p:spPr>
+          <a:xfrm>
+            <a:off x="5852160" y="3511296"/>
+            <a:ext cx="1325880" cy="411480"/>
+          </a:xfrm>
+          <a:prstGeom prst="rect">
+            <a:avLst/>
+          </a:prstGeom>
+          <a:noFill/>
+          <a:ln/>
+        </p:spPr>
+        <p:txBody>
+          <a:bodyPr wrap="square" lIns="0" tIns="0" rIns="0" bIns="0" rtlCol="0" anchor="ctr"/>
+          <a:lstStyle/>
+          <a:p>
+            <a:pPr indent="0" marL="0">
+              <a:buNone/>
+            </a:pPr>
+            <a:r>
+              <a:rPr lang="en-US" sz="1400" b="1" dirty="0">
+                <a:solidFill>
+                  <a:srgbClr val="FFFFFF"/>
+                </a:solidFill>
+                <a:latin typeface="Arial" pitchFamily="34" charset="0"/>
+                <a:ea typeface="Arial" pitchFamily="34" charset="-122"/>
+                <a:cs typeface="Arial" pitchFamily="34" charset="-120"/>
+              </a:rPr>
+              <a:t>Avril – mai</a:t>
+            </a:r>
+            <a:endParaRPr lang="en-US" sz="1400" dirty="0"/>
+          </a:p>
+        </p:txBody>
+      </p:sp>
+      <p:sp>
+        <p:nvSpPr>
+          <p:cNvPr id="19" name="Text 16"/>
+          <p:cNvSpPr txBox="1"/>
+          <p:nvPr/>
+        </p:nvSpPr>
+        <p:spPr>
+          <a:xfrm>
+            <a:off x="7223760" y="3511296"/>
+            <a:ext cx="1828800" cy="411480"/>
+          </a:xfrm>
+          <a:prstGeom prst="rect">
+            <a:avLst/>
+          </a:prstGeom>
+          <a:noFill/>
+          <a:ln/>
+        </p:spPr>
+        <p:txBody>
+          <a:bodyPr wrap="square" lIns="0" tIns="0" rIns="0" bIns="0" rtlCol="0" anchor="ctr"/>
+          <a:lstStyle/>
+          <a:p>
+            <a:pPr indent="0" marL="0">
+              <a:buNone/>
+            </a:pPr>
+            <a:r>
+              <a:rPr lang="en-US" sz="1400" dirty="0">
+                <a:solidFill>
+                  <a:srgbClr val="FFFFFF"/>
+                </a:solidFill>
+                <a:latin typeface="Arial" pitchFamily="34" charset="0"/>
+                <a:ea typeface="Arial" pitchFamily="34" charset="-122"/>
+                <a:cs typeface="Arial" pitchFamily="34" charset="-120"/>
+              </a:rPr>
+              <a:t>Reprise des dalles</a:t>
+            </a:r>
+            <a:endParaRPr lang="en-US" sz="1400" dirty="0"/>
+          </a:p>
+        </p:txBody>
+      </p:sp>
+      <p:sp>
+        <p:nvSpPr>
+          <p:cNvPr id="20" name="Shape 17"/>
+          <p:cNvSpPr/>
+          <p:nvPr/>
+        </p:nvSpPr>
+        <p:spPr>
+          <a:xfrm>
+            <a:off x="9098280" y="3602736"/>
+            <a:ext cx="1417320" cy="228600"/>
+          </a:xfrm>
+          <a:prstGeom prst="rect">
+            <a:avLst/>
+          </a:prstGeom>
+          <a:solidFill>
+            <a:srgbClr val="72C493"/>
+          </a:solidFill>
+          <a:ln/>
+        </p:spPr>
+      </p:sp>
+      <p:sp>
+        <p:nvSpPr>
+          <p:cNvPr id="21" name="Text 18"/>
+          <p:cNvSpPr txBox="1"/>
+          <p:nvPr/>
+        </p:nvSpPr>
+        <p:spPr>
+          <a:xfrm>
+            <a:off x="10607040" y="3511296"/>
+            <a:ext cx="1097280" cy="411480"/>
+          </a:xfrm>
+          <a:prstGeom prst="rect">
+            <a:avLst/>
+          </a:prstGeom>
+          <a:noFill/>
+          <a:ln/>
+        </p:spPr>
+        <p:txBody>
+          <a:bodyPr wrap="square" lIns="0" tIns="0" rIns="0" bIns="0" rtlCol="0" anchor="ctr"/>
+          <a:lstStyle/>
+          <a:p>
+            <a:pPr indent="0" marL="0">
+              <a:buNone/>
+            </a:pPr>
+            <a:r>
+              <a:rPr lang="en-US" sz="1400" b="1" dirty="0">
+                <a:solidFill>
+                  <a:srgbClr val="FFFFFF"/>
+                </a:solidFill>
+                <a:latin typeface="Arial" pitchFamily="34" charset="0"/>
+                <a:ea typeface="Arial" pitchFamily="34" charset="-122"/>
+                <a:cs typeface="Arial" pitchFamily="34" charset="-120"/>
+              </a:rPr>
+              <a:t>109 000 €</a:t>
+            </a:r>
+            <a:endParaRPr lang="en-US" sz="1400" dirty="0"/>
+          </a:p>
+        </p:txBody>
+      </p:sp>
+      <p:sp>
+        <p:nvSpPr>
+          <p:cNvPr id="22" name="Text 19"/>
+          <p:cNvSpPr txBox="1"/>
+          <p:nvPr/>
+        </p:nvSpPr>
+        <p:spPr>
+          <a:xfrm>
+            <a:off x="5852160" y="4078224"/>
+            <a:ext cx="1325880" cy="411480"/>
+          </a:xfrm>
+          <a:prstGeom prst="rect">
+            <a:avLst/>
+          </a:prstGeom>
+          <a:noFill/>
+          <a:ln/>
+        </p:spPr>
+        <p:txBody>
+          <a:bodyPr wrap="square" lIns="0" tIns="0" rIns="0" bIns="0" rtlCol="0" anchor="ctr"/>
+          <a:lstStyle/>
+          <a:p>
+            <a:pPr indent="0" marL="0">
+              <a:buNone/>
+            </a:pPr>
+            <a:r>
+              <a:rPr lang="en-US" sz="1400" b="1" dirty="0">
+                <a:solidFill>
+                  <a:srgbClr val="FFFFFF"/>
+                </a:solidFill>
+                <a:latin typeface="Arial" pitchFamily="34" charset="0"/>
+                <a:ea typeface="Arial" pitchFamily="34" charset="-122"/>
+                <a:cs typeface="Arial" pitchFamily="34" charset="-120"/>
+              </a:rPr>
+              <a:t>Mai – juin</a:t>
+            </a:r>
+            <a:endParaRPr lang="en-US" sz="1400" dirty="0"/>
+          </a:p>
+        </p:txBody>
+      </p:sp>
+      <p:sp>
+        <p:nvSpPr>
+          <p:cNvPr id="23" name="Text 20"/>
+          <p:cNvSpPr txBox="1"/>
+          <p:nvPr/>
+        </p:nvSpPr>
+        <p:spPr>
+          <a:xfrm>
+            <a:off x="7223760" y="4078224"/>
+            <a:ext cx="1828800" cy="411480"/>
+          </a:xfrm>
+          <a:prstGeom prst="rect">
+            <a:avLst/>
+          </a:prstGeom>
+          <a:noFill/>
+          <a:ln/>
+        </p:spPr>
+        <p:txBody>
+          <a:bodyPr wrap="square" lIns="0" tIns="0" rIns="0" bIns="0" rtlCol="0" anchor="ctr"/>
+          <a:lstStyle/>
+          <a:p>
+            <a:pPr indent="0" marL="0">
+              <a:buNone/>
+            </a:pPr>
+            <a:r>
+              <a:rPr lang="en-US" sz="1400" dirty="0">
+                <a:solidFill>
+                  <a:srgbClr val="FFFFFF"/>
+                </a:solidFill>
+                <a:latin typeface="Arial" pitchFamily="34" charset="0"/>
+                <a:ea typeface="Arial" pitchFamily="34" charset="-122"/>
+                <a:cs typeface="Arial" pitchFamily="34" charset="-120"/>
+              </a:rPr>
+              <a:t>Reprise des dalles</a:t>
+            </a:r>
+            <a:endParaRPr lang="en-US" sz="1400" dirty="0"/>
+          </a:p>
+        </p:txBody>
+      </p:sp>
+      <p:sp>
+        <p:nvSpPr>
+          <p:cNvPr id="24" name="Shape 21"/>
+          <p:cNvSpPr/>
+          <p:nvPr/>
+        </p:nvSpPr>
+        <p:spPr>
+          <a:xfrm>
+            <a:off x="9098280" y="4169664"/>
+            <a:ext cx="702159" cy="228600"/>
+          </a:xfrm>
+          <a:prstGeom prst="rect">
+            <a:avLst/>
+          </a:prstGeom>
+          <a:solidFill>
+            <a:srgbClr val="72C493"/>
+          </a:solidFill>
+          <a:ln/>
+        </p:spPr>
+      </p:sp>
+      <p:sp>
+        <p:nvSpPr>
+          <p:cNvPr id="25" name="Text 22"/>
+          <p:cNvSpPr txBox="1"/>
+          <p:nvPr/>
+        </p:nvSpPr>
+        <p:spPr>
+          <a:xfrm>
+            <a:off x="9891879" y="4078224"/>
+            <a:ext cx="1097280" cy="411480"/>
+          </a:xfrm>
+          <a:prstGeom prst="rect">
+            <a:avLst/>
+          </a:prstGeom>
+          <a:noFill/>
+          <a:ln/>
+        </p:spPr>
+        <p:txBody>
+          <a:bodyPr wrap="square" lIns="0" tIns="0" rIns="0" bIns="0" rtlCol="0" anchor="ctr"/>
+          <a:lstStyle/>
+          <a:p>
+            <a:pPr indent="0" marL="0">
+              <a:buNone/>
+            </a:pPr>
+            <a:r>
+              <a:rPr lang="en-US" sz="1400" b="1" dirty="0">
+                <a:solidFill>
+                  <a:srgbClr val="FFFFFF"/>
+                </a:solidFill>
+                <a:latin typeface="Arial" pitchFamily="34" charset="0"/>
+                <a:ea typeface="Arial" pitchFamily="34" charset="-122"/>
+                <a:cs typeface="Arial" pitchFamily="34" charset="-120"/>
+              </a:rPr>
+              <a:t>54 000 €</a:t>
+            </a:r>
+            <a:endParaRPr lang="en-US" sz="1400" dirty="0"/>
+          </a:p>
+        </p:txBody>
+      </p:sp>
+      <p:sp>
+        <p:nvSpPr>
+          <p:cNvPr id="26" name="Text 23"/>
+          <p:cNvSpPr txBox="1"/>
+          <p:nvPr/>
+        </p:nvSpPr>
+        <p:spPr>
+          <a:xfrm>
+            <a:off x="5852160" y="4645152"/>
+            <a:ext cx="1325880" cy="411480"/>
+          </a:xfrm>
+          <a:prstGeom prst="rect">
+            <a:avLst/>
+          </a:prstGeom>
+          <a:noFill/>
+          <a:ln/>
+        </p:spPr>
+        <p:txBody>
+          <a:bodyPr wrap="square" lIns="0" tIns="0" rIns="0" bIns="0" rtlCol="0" anchor="ctr"/>
+          <a:lstStyle/>
+          <a:p>
+            <a:pPr indent="0" marL="0">
+              <a:buNone/>
+            </a:pPr>
+            <a:r>
+              <a:rPr lang="en-US" sz="1400" b="1" dirty="0">
+                <a:solidFill>
+                  <a:srgbClr val="FFFFFF"/>
+                </a:solidFill>
+                <a:latin typeface="Arial" pitchFamily="34" charset="0"/>
+                <a:ea typeface="Arial" pitchFamily="34" charset="-122"/>
+                <a:cs typeface="Arial" pitchFamily="34" charset="-120"/>
+              </a:rPr>
+              <a:t>Août – sept.</a:t>
+            </a:r>
+            <a:endParaRPr lang="en-US" sz="1400" dirty="0"/>
+          </a:p>
+        </p:txBody>
+      </p:sp>
+      <p:sp>
+        <p:nvSpPr>
+          <p:cNvPr id="27" name="Text 24"/>
+          <p:cNvSpPr txBox="1"/>
+          <p:nvPr/>
+        </p:nvSpPr>
+        <p:spPr>
+          <a:xfrm>
+            <a:off x="7223760" y="4645152"/>
+            <a:ext cx="1828800" cy="411480"/>
+          </a:xfrm>
+          <a:prstGeom prst="rect">
+            <a:avLst/>
+          </a:prstGeom>
+          <a:noFill/>
+          <a:ln/>
+        </p:spPr>
+        <p:txBody>
+          <a:bodyPr wrap="square" lIns="0" tIns="0" rIns="0" bIns="0" rtlCol="0" anchor="ctr"/>
+          <a:lstStyle/>
+          <a:p>
+            <a:pPr indent="0" marL="0">
+              <a:buNone/>
+            </a:pPr>
+            <a:r>
+              <a:rPr lang="en-US" sz="1400" dirty="0">
+                <a:solidFill>
+                  <a:srgbClr val="FFFFFF"/>
+                </a:solidFill>
+                <a:latin typeface="Arial" pitchFamily="34" charset="0"/>
+                <a:ea typeface="Arial" pitchFamily="34" charset="-122"/>
+                <a:cs typeface="Arial" pitchFamily="34" charset="-120"/>
+              </a:rPr>
+              <a:t>Lames composites</a:t>
+            </a:r>
+            <a:endParaRPr lang="en-US" sz="1400" dirty="0"/>
+          </a:p>
+        </p:txBody>
+      </p:sp>
+      <p:sp>
+        <p:nvSpPr>
+          <p:cNvPr id="28" name="Shape 25"/>
+          <p:cNvSpPr/>
+          <p:nvPr/>
+        </p:nvSpPr>
+        <p:spPr>
+          <a:xfrm>
+            <a:off x="9098280" y="4736592"/>
+            <a:ext cx="897203" cy="228600"/>
+          </a:xfrm>
+          <a:prstGeom prst="rect">
+            <a:avLst/>
+          </a:prstGeom>
+          <a:solidFill>
+            <a:srgbClr val="72C493"/>
+          </a:solidFill>
+          <a:ln/>
+        </p:spPr>
+      </p:sp>
+      <p:sp>
+        <p:nvSpPr>
+          <p:cNvPr id="29" name="Text 26"/>
+          <p:cNvSpPr txBox="1"/>
+          <p:nvPr/>
+        </p:nvSpPr>
+        <p:spPr>
+          <a:xfrm>
+            <a:off x="10086923" y="4645152"/>
+            <a:ext cx="1097280" cy="411480"/>
+          </a:xfrm>
+          <a:prstGeom prst="rect">
+            <a:avLst/>
+          </a:prstGeom>
+          <a:noFill/>
+          <a:ln/>
+        </p:spPr>
+        <p:txBody>
+          <a:bodyPr wrap="square" lIns="0" tIns="0" rIns="0" bIns="0" rtlCol="0" anchor="ctr"/>
+          <a:lstStyle/>
+          <a:p>
+            <a:pPr indent="0" marL="0">
+              <a:buNone/>
+            </a:pPr>
+            <a:r>
+              <a:rPr lang="en-US" sz="1400" b="1" dirty="0">
+                <a:solidFill>
+                  <a:srgbClr val="FFFFFF"/>
+                </a:solidFill>
+                <a:latin typeface="Arial" pitchFamily="34" charset="0"/>
+                <a:ea typeface="Arial" pitchFamily="34" charset="-122"/>
+                <a:cs typeface="Arial" pitchFamily="34" charset="-120"/>
+              </a:rPr>
+              <a:t>69 000 €</a:t>
+            </a:r>
+            <a:endParaRPr lang="en-US" sz="1400" dirty="0"/>
+          </a:p>
+        </p:txBody>
+      </p:sp>
+      <p:sp>
+        <p:nvSpPr>
+          <p:cNvPr id="30" name="Shape 27"/>
+          <p:cNvSpPr/>
+          <p:nvPr/>
+        </p:nvSpPr>
+        <p:spPr>
+          <a:xfrm>
+            <a:off x="630936" y="3794760"/>
+            <a:ext cx="4754880" cy="2514600"/>
+          </a:xfrm>
+          <a:prstGeom prst="rect">
+            <a:avLst/>
+          </a:prstGeom>
+          <a:solidFill>
+            <a:srgbClr val="16296E"/>
+          </a:solidFill>
+          <a:ln/>
+        </p:spPr>
+      </p:sp>
+      <p:sp>
+        <p:nvSpPr>
+          <p:cNvPr id="31" name="Text 28"/>
+          <p:cNvSpPr txBox="1"/>
+          <p:nvPr/>
+        </p:nvSpPr>
+        <p:spPr>
+          <a:xfrm>
+            <a:off x="914400" y="4023360"/>
+            <a:ext cx="4297680" cy="320040"/>
+          </a:xfrm>
+          <a:prstGeom prst="rect">
+            <a:avLst/>
+          </a:prstGeom>
+          <a:noFill/>
+          <a:ln/>
+        </p:spPr>
+        <p:txBody>
+          <a:bodyPr wrap="square" lIns="0" tIns="0" rIns="0" bIns="0" rtlCol="0" anchor="ctr"/>
+          <a:lstStyle/>
+          <a:p>
+            <a:pPr indent="0" marL="0">
+              <a:buNone/>
+            </a:pPr>
+            <a:r>
+              <a:rPr lang="en-US" sz="1400" b="1" spc="200" kern="0" dirty="0">
+                <a:solidFill>
+                  <a:srgbClr val="72C493"/>
+                </a:solidFill>
+                <a:latin typeface="Arial" pitchFamily="34" charset="0"/>
+                <a:ea typeface="Arial" pitchFamily="34" charset="-122"/>
+                <a:cs typeface="Arial" pitchFamily="34" charset="-120"/>
+              </a:rPr>
+              <a:t>PROCHAINES INTERVENTIONS</a:t>
+            </a:r>
+            <a:endParaRPr lang="en-US" sz="1400" dirty="0"/>
+          </a:p>
+        </p:txBody>
+      </p:sp>
+      <p:sp>
+        <p:nvSpPr>
+          <p:cNvPr id="32" name="Text 29"/>
+          <p:cNvSpPr txBox="1"/>
+          <p:nvPr/>
+        </p:nvSpPr>
+        <p:spPr>
+          <a:xfrm>
+            <a:off x="914400" y="4480560"/>
+            <a:ext cx="4206240" cy="1133856"/>
+          </a:xfrm>
+          <a:prstGeom prst="rect">
+            <a:avLst/>
+          </a:prstGeom>
+          <a:noFill/>
+          <a:ln/>
+        </p:spPr>
+        <p:txBody>
+          <a:bodyPr wrap="square" lIns="0" tIns="0" rIns="0" bIns="0" rtlCol="0" anchor="t"/>
+          <a:lstStyle/>
+          <a:p>
+            <a:pPr marL="203200" indent="-203200">
+              <a:spcAft>
+                <a:spcPts val="800"/>
+              </a:spcAft>
+              <a:buSzPct val="100000"/>
+              <a:buChar char="•"/>
+            </a:pPr>
+            <a:r>
+              <a:rPr lang="en-US" sz="1500" dirty="0">
+                <a:solidFill>
+                  <a:srgbClr val="FFFFFF"/>
+                </a:solidFill>
+                <a:latin typeface="Arial" pitchFamily="34" charset="0"/>
+                <a:ea typeface="Arial" pitchFamily="34" charset="-122"/>
+                <a:cs typeface="Arial" pitchFamily="34" charset="-120"/>
+              </a:rPr>
+              <a:t>Zone 7, devant l’opticien et le centre d’ophtalmologie</a:t>
+            </a:r>
+            <a:endParaRPr lang="en-US" sz="1500" dirty="0"/>
+          </a:p>
+          <a:p>
+            <a:pPr marL="203200" indent="-203200">
+              <a:spcAft>
+                <a:spcPts val="800"/>
+              </a:spcAft>
+              <a:buSzPct val="100000"/>
+              <a:buChar char="•"/>
+            </a:pPr>
+            <a:r>
+              <a:rPr lang="en-US" sz="1500" dirty="0">
+                <a:solidFill>
+                  <a:srgbClr val="FFFFFF"/>
+                </a:solidFill>
+                <a:latin typeface="Arial" pitchFamily="34" charset="0"/>
+                <a:ea typeface="Arial" pitchFamily="34" charset="-122"/>
+                <a:cs typeface="Arial" pitchFamily="34" charset="-120"/>
+              </a:rPr>
+              <a:t>Zone 62, devant le magasin de sport</a:t>
+            </a:r>
+            <a:endParaRPr lang="en-US" sz="1500" dirty="0"/>
+          </a:p>
+        </p:txBody>
+      </p:sp>
+      <p:sp>
+        <p:nvSpPr>
+          <p:cNvPr id="33" name="Text 30"/>
+          <p:cNvSpPr txBox="1"/>
+          <p:nvPr/>
+        </p:nvSpPr>
+        <p:spPr>
+          <a:xfrm>
+            <a:off x="5852160" y="5349240"/>
+            <a:ext cx="5715000" cy="640080"/>
+          </a:xfrm>
+          <a:prstGeom prst="rect">
+            <a:avLst/>
+          </a:prstGeom>
+          <a:noFill/>
+          <a:ln/>
+        </p:spPr>
+        <p:txBody>
+          <a:bodyPr wrap="square" lIns="0" tIns="0" rIns="0" bIns="0" rtlCol="0" anchor="t"/>
+          <a:lstStyle/>
+          <a:p>
+            <a:pPr indent="0" marL="0">
+              <a:buNone/>
+            </a:pPr>
+            <a:r>
+              <a:rPr lang="en-US" sz="1300" i="1" dirty="0">
+                <a:solidFill>
+                  <a:srgbClr val="8A90B0"/>
+                </a:solidFill>
+                <a:latin typeface="Arial" pitchFamily="34" charset="0"/>
+                <a:ea typeface="Arial" pitchFamily="34" charset="-122"/>
+                <a:cs typeface="Arial" pitchFamily="34" charset="-120"/>
+              </a:rPr>
+              <a:t>Lames composites : 60 % de plastique recyclable (PEHD) et 40 % de bois recyclé</a:t>
+            </a:r>
+            <a:endParaRPr lang="en-US" sz="1300" dirty="0"/>
           </a:p>
         </p:txBody>
       </p:sp>

</xml_diff>